<commit_message>
Finalize CDM and IRT modules, fix API bugs, test coverage, polish frontend UI
</commit_message>
<xml_diff>
--- a/ppts/cdm/1.pptx
+++ b/ppts/cdm/1.pptx
@@ -4,6 +4,9 @@
   <p:sldMasterIdLst>
     <p:sldMasterId id="2147483648" r:id="rId1"/>
   </p:sldMasterIdLst>
+  <p:notesMasterIdLst>
+    <p:notesMasterId r:id="rId14"/>
+  </p:notesMasterIdLst>
   <p:sldIdLst>
     <p:sldId id="256" r:id="rId2"/>
     <p:sldId id="257" r:id="rId3"/>
@@ -18,17 +21,114 @@
     <p:sldId id="266" r:id="rId12"/>
     <p:sldId id="267" r:id="rId13"/>
   </p:sldIdLst>
-  <p:notesMasterIdLst>
-    <p:notesMasterId r:id="rId14"/>
-  </p:notesMasterIdLst>
   <p:sldSz cx="12192000" cy="6858000"/>
   <p:notesSz cx="6858000" cy="12192000"/>
   <p:embeddedFontLst>
     <p:embeddedFont>
-      <p:font typeface="Liter" charset="-122" pitchFamily="34"/>
-      <p:regular r:id="rId19"/>
+      <p:font typeface="Liter" panose="020B0604020202020204" charset="0"/>
+      <p:regular r:id="rId15"/>
     </p:embeddedFont>
   </p:embeddedFontLst>
+  <p:defaultTextStyle>
+    <a:defPPr>
+      <a:defRPr lang="en-US"/>
+    </a:defPPr>
+    <a:lvl1pPr marL="0" algn="l" defTabSz="914400" rtl="0" eaLnBrk="1" latinLnBrk="0" hangingPunct="1">
+      <a:defRPr sz="1800" kern="1200">
+        <a:solidFill>
+          <a:schemeClr val="tx1"/>
+        </a:solidFill>
+        <a:latin typeface="+mn-lt"/>
+        <a:ea typeface="+mn-ea"/>
+        <a:cs typeface="+mn-cs"/>
+      </a:defRPr>
+    </a:lvl1pPr>
+    <a:lvl2pPr marL="457200" algn="l" defTabSz="914400" rtl="0" eaLnBrk="1" latinLnBrk="0" hangingPunct="1">
+      <a:defRPr sz="1800" kern="1200">
+        <a:solidFill>
+          <a:schemeClr val="tx1"/>
+        </a:solidFill>
+        <a:latin typeface="+mn-lt"/>
+        <a:ea typeface="+mn-ea"/>
+        <a:cs typeface="+mn-cs"/>
+      </a:defRPr>
+    </a:lvl2pPr>
+    <a:lvl3pPr marL="914400" algn="l" defTabSz="914400" rtl="0" eaLnBrk="1" latinLnBrk="0" hangingPunct="1">
+      <a:defRPr sz="1800" kern="1200">
+        <a:solidFill>
+          <a:schemeClr val="tx1"/>
+        </a:solidFill>
+        <a:latin typeface="+mn-lt"/>
+        <a:ea typeface="+mn-ea"/>
+        <a:cs typeface="+mn-cs"/>
+      </a:defRPr>
+    </a:lvl3pPr>
+    <a:lvl4pPr marL="1371600" algn="l" defTabSz="914400" rtl="0" eaLnBrk="1" latinLnBrk="0" hangingPunct="1">
+      <a:defRPr sz="1800" kern="1200">
+        <a:solidFill>
+          <a:schemeClr val="tx1"/>
+        </a:solidFill>
+        <a:latin typeface="+mn-lt"/>
+        <a:ea typeface="+mn-ea"/>
+        <a:cs typeface="+mn-cs"/>
+      </a:defRPr>
+    </a:lvl4pPr>
+    <a:lvl5pPr marL="1828800" algn="l" defTabSz="914400" rtl="0" eaLnBrk="1" latinLnBrk="0" hangingPunct="1">
+      <a:defRPr sz="1800" kern="1200">
+        <a:solidFill>
+          <a:schemeClr val="tx1"/>
+        </a:solidFill>
+        <a:latin typeface="+mn-lt"/>
+        <a:ea typeface="+mn-ea"/>
+        <a:cs typeface="+mn-cs"/>
+      </a:defRPr>
+    </a:lvl5pPr>
+    <a:lvl6pPr marL="2286000" algn="l" defTabSz="914400" rtl="0" eaLnBrk="1" latinLnBrk="0" hangingPunct="1">
+      <a:defRPr sz="1800" kern="1200">
+        <a:solidFill>
+          <a:schemeClr val="tx1"/>
+        </a:solidFill>
+        <a:latin typeface="+mn-lt"/>
+        <a:ea typeface="+mn-ea"/>
+        <a:cs typeface="+mn-cs"/>
+      </a:defRPr>
+    </a:lvl6pPr>
+    <a:lvl7pPr marL="2743200" algn="l" defTabSz="914400" rtl="0" eaLnBrk="1" latinLnBrk="0" hangingPunct="1">
+      <a:defRPr sz="1800" kern="1200">
+        <a:solidFill>
+          <a:schemeClr val="tx1"/>
+        </a:solidFill>
+        <a:latin typeface="+mn-lt"/>
+        <a:ea typeface="+mn-ea"/>
+        <a:cs typeface="+mn-cs"/>
+      </a:defRPr>
+    </a:lvl7pPr>
+    <a:lvl8pPr marL="3200400" algn="l" defTabSz="914400" rtl="0" eaLnBrk="1" latinLnBrk="0" hangingPunct="1">
+      <a:defRPr sz="1800" kern="1200">
+        <a:solidFill>
+          <a:schemeClr val="tx1"/>
+        </a:solidFill>
+        <a:latin typeface="+mn-lt"/>
+        <a:ea typeface="+mn-ea"/>
+        <a:cs typeface="+mn-cs"/>
+      </a:defRPr>
+    </a:lvl8pPr>
+    <a:lvl9pPr marL="3657600" algn="l" defTabSz="914400" rtl="0" eaLnBrk="1" latinLnBrk="0" hangingPunct="1">
+      <a:defRPr sz="1800" kern="1200">
+        <a:solidFill>
+          <a:schemeClr val="tx1"/>
+        </a:solidFill>
+        <a:latin typeface="+mn-lt"/>
+        <a:ea typeface="+mn-ea"/>
+        <a:cs typeface="+mn-cs"/>
+      </a:defRPr>
+    </a:lvl9pPr>
+  </p:defaultTextStyle>
+  <p:extLst>
+    <p:ext uri="{EFAFB233-063F-42B5-8137-9DF3F51BA10A}">
+      <p15:sldGuideLst xmlns:p15="http://schemas.microsoft.com/office/powerpoint/2012/main"/>
+    </p:ext>
+  </p:extLst>
 </p:presentation>
 </file>
 
@@ -54,234 +154,10 @@
           <a:chExt cx="0" cy="0"/>
         </a:xfrm>
       </p:grpSpPr>
-      <p:sp>
-        <p:nvSpPr>
-          <p:cNvPr id="2" name="Header Placeholder 1"/>
-          <p:cNvSpPr>
-            <a:spLocks noGrp="1"/>
-          </p:cNvSpPr>
-          <p:nvPr>
-            <p:ph type="hdr" sz="quarter"/>
-          </p:nvPr>
-        </p:nvSpPr>
-        <p:spPr>
-          <a:xfrm>
-            <a:off x="0" y="0"/>
-            <a:ext cx="2971800" cy="458788"/>
-          </a:xfrm>
-          <a:prstGeom prst="rect">
-            <a:avLst/>
-          </a:prstGeom>
-        </p:spPr>
-        <p:txBody>
-          <a:bodyPr vert="horz" lIns="91440" tIns="45720" rIns="91440" bIns="45720" rtlCol="0"/>
-          <a:lstStyle>
-            <a:lvl1pPr algn="l">
-              <a:defRPr sz="1200"/>
-            </a:lvl1pPr>
-          </a:lstStyle>
-          <a:p>
-            <a:endParaRPr lang="en-US"/>
-          </a:p>
-        </p:txBody>
-      </p:sp>
-      <p:sp>
-        <p:nvSpPr>
-          <p:cNvPr id="3" name="Date Placeholder 2"/>
-          <p:cNvSpPr>
-            <a:spLocks noGrp="1"/>
-          </p:cNvSpPr>
-          <p:nvPr>
-            <p:ph type="dt" idx="1"/>
-          </p:nvPr>
-        </p:nvSpPr>
-        <p:spPr>
-          <a:xfrm>
-            <a:off x="3884613" y="0"/>
-            <a:ext cx="2971800" cy="458788"/>
-          </a:xfrm>
-          <a:prstGeom prst="rect">
-            <a:avLst/>
-          </a:prstGeom>
-        </p:spPr>
-        <p:txBody>
-          <a:bodyPr vert="horz" lIns="91440" tIns="45720" rIns="91440" bIns="45720" rtlCol="0"/>
-          <a:lstStyle>
-            <a:lvl1pPr algn="r">
-              <a:defRPr sz="1200"/>
-            </a:lvl1pPr>
-          </a:lstStyle>
-          <a:p>
-            <a:fld id="{5282F153-3F37-0F45-9E97-73ACFA13230C}" type="datetimeFigureOut">
-              <a:rPr lang="en-US"/>
-              <a:t>7/23/19</a:t>
-            </a:fld>
-            <a:endParaRPr lang="en-US"/>
-          </a:p>
-        </p:txBody>
-      </p:sp>
-      <p:sp>
-        <p:nvSpPr>
-          <p:cNvPr id="4" name="Slide Image Placeholder 3"/>
-          <p:cNvSpPr>
-            <a:spLocks noGrp="1" noRot="1" noChangeAspect="1"/>
-          </p:cNvSpPr>
-          <p:nvPr>
-            <p:ph type="sldImg" idx="2"/>
-          </p:nvPr>
-        </p:nvSpPr>
-        <p:spPr>
-          <a:xfrm>
-            <a:off x="685800" y="1143000"/>
-            <a:ext cx="5486400" cy="3086100"/>
-          </a:xfrm>
-          <a:prstGeom prst="rect">
-            <a:avLst/>
-          </a:prstGeom>
-          <a:noFill/>
-          <a:ln w="12700">
-            <a:solidFill>
-              <a:prstClr val="black"/>
-            </a:solidFill>
-          </a:ln>
-        </p:spPr>
-        <p:txBody>
-          <a:bodyPr vert="horz" lIns="91440" tIns="45720" rIns="91440" bIns="45720" rtlCol="0" anchor="ctr"/>
-          <a:lstStyle/>
-          <a:p>
-            <a:endParaRPr lang="en-US"/>
-          </a:p>
-        </p:txBody>
-      </p:sp>
-      <p:sp>
-        <p:nvSpPr>
-          <p:cNvPr id="5" name="Notes Placeholder 4"/>
-          <p:cNvSpPr>
-            <a:spLocks noGrp="1"/>
-          </p:cNvSpPr>
-          <p:nvPr>
-            <p:ph type="body" sz="quarter" idx="3"/>
-          </p:nvPr>
-        </p:nvSpPr>
-        <p:spPr>
-          <a:xfrm>
-            <a:off x="685800" y="4400550"/>
-            <a:ext cx="5486400" cy="3600450"/>
-          </a:xfrm>
-          <a:prstGeom prst="rect">
-            <a:avLst/>
-          </a:prstGeom>
-        </p:spPr>
-        <p:txBody>
-          <a:bodyPr vert="horz" lIns="91440" tIns="45720" rIns="91440" bIns="45720" rtlCol="0"/>
-          <a:lstStyle/>
-          <a:p>
-            <a:pPr lvl="0"/>
-            <a:r>
-              <a:rPr lang="en-US"/>
-              <a:t>Click to edit Master text styles</a:t>
-            </a:r>
-          </a:p>
-          <a:p>
-            <a:pPr lvl="1"/>
-            <a:r>
-              <a:rPr lang="en-US"/>
-              <a:t>Second level</a:t>
-            </a:r>
-          </a:p>
-          <a:p>
-            <a:pPr lvl="2"/>
-            <a:r>
-              <a:rPr lang="en-US"/>
-              <a:t>Third level</a:t>
-            </a:r>
-          </a:p>
-          <a:p>
-            <a:pPr lvl="3"/>
-            <a:r>
-              <a:rPr lang="en-US"/>
-              <a:t>Fourth level</a:t>
-            </a:r>
-          </a:p>
-          <a:p>
-            <a:pPr lvl="4"/>
-            <a:r>
-              <a:rPr lang="en-US"/>
-              <a:t>Fifth level</a:t>
-            </a:r>
-          </a:p>
-        </p:txBody>
-      </p:sp>
-      <p:sp>
-        <p:nvSpPr>
-          <p:cNvPr id="6" name="Footer Placeholder 5"/>
-          <p:cNvSpPr>
-            <a:spLocks noGrp="1"/>
-          </p:cNvSpPr>
-          <p:nvPr>
-            <p:ph type="ftr" sz="quarter" idx="4"/>
-          </p:nvPr>
-        </p:nvSpPr>
-        <p:spPr>
-          <a:xfrm>
-            <a:off x="0" y="8685213"/>
-            <a:ext cx="2971800" cy="458787"/>
-          </a:xfrm>
-          <a:prstGeom prst="rect">
-            <a:avLst/>
-          </a:prstGeom>
-        </p:spPr>
-        <p:txBody>
-          <a:bodyPr vert="horz" lIns="91440" tIns="45720" rIns="91440" bIns="45720" rtlCol="0" anchor="b"/>
-          <a:lstStyle>
-            <a:lvl1pPr algn="l">
-              <a:defRPr sz="1200"/>
-            </a:lvl1pPr>
-          </a:lstStyle>
-          <a:p>
-            <a:endParaRPr lang="en-US"/>
-          </a:p>
-        </p:txBody>
-      </p:sp>
-      <p:sp>
-        <p:nvSpPr>
-          <p:cNvPr id="7" name="Slide Number Placeholder 6"/>
-          <p:cNvSpPr>
-            <a:spLocks noGrp="1"/>
-          </p:cNvSpPr>
-          <p:nvPr>
-            <p:ph type="sldNum" sz="quarter" idx="5"/>
-          </p:nvPr>
-        </p:nvSpPr>
-        <p:spPr>
-          <a:xfrm>
-            <a:off x="3884613" y="8685213"/>
-            <a:ext cx="2971800" cy="458787"/>
-          </a:xfrm>
-          <a:prstGeom prst="rect">
-            <a:avLst/>
-          </a:prstGeom>
-        </p:spPr>
-        <p:txBody>
-          <a:bodyPr vert="horz" lIns="91440" tIns="45720" rIns="91440" bIns="45720" rtlCol="0" anchor="b"/>
-          <a:lstStyle>
-            <a:lvl1pPr algn="r">
-              <a:defRPr sz="1200"/>
-            </a:lvl1pPr>
-          </a:lstStyle>
-          <a:p>
-            <a:fld id="{CE5E9CC1-C706-0F49-92D6-E571CC5EEA8F}" type="slidenum">
-              <a:rPr lang="en-US"/>
-              <a:t>‹#›</a:t>
-            </a:fld>
-            <a:endParaRPr lang="en-US"/>
-          </a:p>
-        </p:txBody>
-      </p:sp>
     </p:spTree>
     <p:extLst>
       <p:ext uri="{BB962C8B-B14F-4D97-AF65-F5344CB8AC3E}">
-        <p14:creationId xmlns:p14="http://schemas.microsoft.com/office/powerpoint/2010/main" val="1024086991"/>
+        <p14:creationId xmlns:p14="http://schemas.microsoft.com/office/powerpoint/2010/main" val="3882547918"/>
       </p:ext>
     </p:extLst>
   </p:cSld>
@@ -425,10 +301,6 @@
           <a:bodyPr/>
           <a:lstStyle/>
           <a:p>
-            <a:r>
-              <a:rPr lang="en-US" dirty="0"/>
-              <a:t/>
-            </a:r>
             <a:endParaRPr lang="en-US" dirty="0"/>
           </a:p>
         </p:txBody>
@@ -513,10 +385,6 @@
           <a:bodyPr/>
           <a:lstStyle/>
           <a:p>
-            <a:r>
-              <a:rPr lang="en-US" dirty="0"/>
-              <a:t/>
-            </a:r>
             <a:endParaRPr lang="en-US" dirty="0"/>
           </a:p>
         </p:txBody>
@@ -601,10 +469,6 @@
           <a:bodyPr/>
           <a:lstStyle/>
           <a:p>
-            <a:r>
-              <a:rPr lang="en-US" dirty="0"/>
-              <a:t/>
-            </a:r>
             <a:endParaRPr lang="en-US" dirty="0"/>
           </a:p>
         </p:txBody>
@@ -689,10 +553,6 @@
           <a:bodyPr/>
           <a:lstStyle/>
           <a:p>
-            <a:r>
-              <a:rPr lang="en-US" dirty="0"/>
-              <a:t/>
-            </a:r>
             <a:endParaRPr lang="en-US" dirty="0"/>
           </a:p>
         </p:txBody>
@@ -777,10 +637,6 @@
           <a:bodyPr/>
           <a:lstStyle/>
           <a:p>
-            <a:r>
-              <a:rPr lang="en-US" dirty="0"/>
-              <a:t/>
-            </a:r>
             <a:endParaRPr lang="en-US" dirty="0"/>
           </a:p>
         </p:txBody>
@@ -865,10 +721,6 @@
           <a:bodyPr/>
           <a:lstStyle/>
           <a:p>
-            <a:r>
-              <a:rPr lang="en-US" dirty="0"/>
-              <a:t/>
-            </a:r>
             <a:endParaRPr lang="en-US" dirty="0"/>
           </a:p>
         </p:txBody>
@@ -953,10 +805,6 @@
           <a:bodyPr/>
           <a:lstStyle/>
           <a:p>
-            <a:r>
-              <a:rPr lang="en-US" dirty="0"/>
-              <a:t/>
-            </a:r>
             <a:endParaRPr lang="en-US" dirty="0"/>
           </a:p>
         </p:txBody>
@@ -1041,10 +889,6 @@
           <a:bodyPr/>
           <a:lstStyle/>
           <a:p>
-            <a:r>
-              <a:rPr lang="en-US" dirty="0"/>
-              <a:t/>
-            </a:r>
             <a:endParaRPr lang="en-US" dirty="0"/>
           </a:p>
         </p:txBody>
@@ -1129,10 +973,6 @@
           <a:bodyPr/>
           <a:lstStyle/>
           <a:p>
-            <a:r>
-              <a:rPr lang="en-US" dirty="0"/>
-              <a:t/>
-            </a:r>
             <a:endParaRPr lang="en-US" dirty="0"/>
           </a:p>
         </p:txBody>
@@ -1217,10 +1057,6 @@
           <a:bodyPr/>
           <a:lstStyle/>
           <a:p>
-            <a:r>
-              <a:rPr lang="en-US" dirty="0"/>
-              <a:t/>
-            </a:r>
             <a:endParaRPr lang="en-US" dirty="0"/>
           </a:p>
         </p:txBody>
@@ -1305,10 +1141,6 @@
           <a:bodyPr/>
           <a:lstStyle/>
           <a:p>
-            <a:r>
-              <a:rPr lang="en-US" dirty="0"/>
-              <a:t/>
-            </a:r>
             <a:endParaRPr lang="en-US" dirty="0"/>
           </a:p>
         </p:txBody>
@@ -1393,10 +1225,6 @@
           <a:bodyPr/>
           <a:lstStyle/>
           <a:p>
-            <a:r>
-              <a:rPr lang="en-US" dirty="0"/>
-              <a:t/>
-            </a:r>
             <a:endParaRPr lang="en-US" dirty="0"/>
           </a:p>
         </p:txBody>
@@ -1475,6 +1303,7 @@
         <a:solidFill>
           <a:srgbClr val="FFFFFF"/>
         </a:solidFill>
+        <a:effectLst/>
       </p:bgPr>
     </p:bg>
     <p:spTree>
@@ -1502,6 +1331,11 @@
 <file path=ppt/slideMasters/slideMaster1.xml><?xml version="1.0" encoding="utf-8"?>
 <p:sldMaster xmlns:a="http://schemas.openxmlformats.org/drawingml/2006/main" xmlns:r="http://schemas.openxmlformats.org/officeDocument/2006/relationships" xmlns:p="http://schemas.openxmlformats.org/presentationml/2006/main">
   <p:cSld>
+    <p:bg>
+      <p:bgRef idx="1001">
+        <a:schemeClr val="bg1"/>
+      </p:bgRef>
+    </p:bg>
     <p:spTree>
       <p:nvGrpSpPr>
         <p:cNvPr id="1" name=""/>
@@ -1785,6 +1619,7 @@
         <a:solidFill>
           <a:srgbClr val="FAF9F6"/>
         </a:solidFill>
+        <a:effectLst/>
       </p:bgPr>
     </p:bg>
     <p:spTree>
@@ -1803,22 +1638,22 @@
       </p:grpSpPr>
       <p:pic>
         <p:nvPicPr>
-          <p:cNvPr id="2" name="Image 0" descr="preencoded.png">    </p:cNvPr>
+          <p:cNvPr id="2" name="Image 0" descr="preencoded.png"/>
           <p:cNvPicPr>
             <a:picLocks noChangeAspect="1"/>
           </p:cNvPicPr>
           <p:nvPr/>
         </p:nvPicPr>
         <p:blipFill>
-          <a:blip r:embed="rId1">
+          <a:blip>
             <a:alphaModFix amt="6000"/>
             <a:extLst>
               <a:ext uri="{96DAC541-7B7A-43D3-8B79-37D633B846F1}">
-                <asvg:svgBlip xmlns:asvg="http://schemas.microsoft.com/office/drawing/2016/SVG/main" r:embed="rId2"/>
+                <asvg:svgBlip xmlns:asvg="http://schemas.microsoft.com/office/drawing/2016/SVG/main" r:embed="rId3"/>
               </a:ext>
             </a:extLst>
           </a:blip>
-          <a:srcRect l="0" r="0" t="15909" b="15909"/>
+          <a:srcRect t="15909" b="15909"/>
           <a:stretch/>
         </p:blipFill>
         <p:spPr>
@@ -1904,7 +1739,7 @@
               </a:lnSpc>
             </a:pPr>
             <a:r>
-              <a:rPr lang="en-US" sz="1200" spc="360" kern="0" dirty="0">
+              <a:rPr lang="en-US" sz="1200" kern="0" spc="360" dirty="0">
                 <a:solidFill>
                   <a:srgbClr val="A8A29E"/>
                 </a:solidFill>
@@ -2166,10 +2001,18 @@
   <p:clrMapOvr>
     <a:masterClrMapping/>
   </p:clrMapOvr>
-  <p:transition>
-    <p:fade/>
-    <p:spd val="med"/>
-  </p:transition>
+  <mc:AlternateContent xmlns:mc="http://schemas.openxmlformats.org/markup-compatibility/2006">
+    <mc:Choice xmlns:p159="http://schemas.microsoft.com/office/powerpoint/2015/09/main" Requires="p159">
+      <p:transition xmlns:p14="http://schemas.microsoft.com/office/powerpoint/2010/main" spd="slow" p14:dur="2000">
+        <p159:morph option="byObject"/>
+      </p:transition>
+    </mc:Choice>
+    <mc:Fallback>
+      <p:transition spd="slow">
+        <p:fade/>
+      </p:transition>
+    </mc:Fallback>
+  </mc:AlternateContent>
 </p:sld>
 </file>
 
@@ -2181,6 +2024,7 @@
         <a:solidFill>
           <a:srgbClr val="FAF9F6"/>
         </a:solidFill>
+        <a:effectLst/>
       </p:bgPr>
     </p:bg>
     <p:spTree>
@@ -2268,7 +2112,7 @@
               </a:lnSpc>
             </a:pPr>
             <a:r>
-              <a:rPr lang="en-US" sz="1050" spc="210" kern="0" dirty="0">
+              <a:rPr lang="en-US" sz="1050" kern="0" spc="210" dirty="0">
                 <a:solidFill>
                   <a:srgbClr val="A8A29E"/>
                 </a:solidFill>
@@ -2564,7 +2408,7 @@
               </a:lnSpc>
             </a:pPr>
             <a:r>
-              <a:rPr lang="en-US" sz="1050" spc="53" kern="0" dirty="0">
+              <a:rPr lang="en-US" sz="1050" kern="0" spc="53" dirty="0">
                 <a:solidFill>
                   <a:srgbClr val="C4B7A6"/>
                 </a:solidFill>
@@ -2665,15 +2509,15 @@
       </p:sp>
       <p:pic>
         <p:nvPicPr>
-          <p:cNvPr id="13" name="Image 0" descr="https://kimi-img.moonshot.cn/pub/slides/26-03-14-15:13:59-d6qgldvvg7e1pqrqthb0.png">    </p:cNvPr>
+          <p:cNvPr id="13" name="Image 0" descr="https://kimi-img.moonshot.cn/pub/slides/26-03-14-15:13:59-d6qgldvvg7e1pqrqthb0.png"/>
           <p:cNvPicPr>
             <a:picLocks noChangeAspect="1"/>
           </p:cNvPicPr>
           <p:nvPr/>
         </p:nvPicPr>
         <p:blipFill>
-          <a:blip r:embed="rId1"/>
-          <a:srcRect l="0" r="0" t="0" b="0"/>
+          <a:blip r:embed="rId3"/>
+          <a:srcRect/>
           <a:stretch/>
         </p:blipFill>
         <p:spPr>
@@ -2961,7 +2805,6 @@
   </p:clrMapOvr>
   <p:transition>
     <p:fade/>
-    <p:spd val="med"/>
   </p:transition>
 </p:sld>
 </file>
@@ -2974,6 +2817,7 @@
         <a:solidFill>
           <a:srgbClr val="FAF9F6"/>
         </a:solidFill>
+        <a:effectLst/>
       </p:bgPr>
     </p:bg>
     <p:spTree>
@@ -3061,7 +2905,7 @@
               </a:lnSpc>
             </a:pPr>
             <a:r>
-              <a:rPr lang="en-US" sz="1050" spc="210" kern="0" dirty="0">
+              <a:rPr lang="en-US" sz="1050" kern="0" spc="210" dirty="0">
                 <a:solidFill>
                   <a:srgbClr val="A8A29E"/>
                 </a:solidFill>
@@ -4487,7 +4331,7 @@
               </a:lnSpc>
             </a:pPr>
             <a:r>
-              <a:rPr lang="en-US" sz="1050" spc="53" kern="0" dirty="0">
+              <a:rPr lang="en-US" sz="1050" kern="0" spc="53" dirty="0">
                 <a:solidFill>
                   <a:srgbClr val="C4B7A6"/>
                 </a:solidFill>
@@ -4503,15 +4347,15 @@
       </p:sp>
       <p:pic>
         <p:nvPicPr>
-          <p:cNvPr id="33" name="Image 0" descr="https://kimi-img.moonshot.cn/pub/slides/26-03-14-15:14:00-d6qgle4bcdrsrv6751p0.png">    </p:cNvPr>
+          <p:cNvPr id="33" name="Image 0" descr="https://kimi-img.moonshot.cn/pub/slides/26-03-14-15:14:00-d6qgle4bcdrsrv6751p0.png"/>
           <p:cNvPicPr>
             <a:picLocks noChangeAspect="1"/>
           </p:cNvPicPr>
           <p:nvPr/>
         </p:nvPicPr>
         <p:blipFill>
-          <a:blip r:embed="rId1"/>
-          <a:srcRect l="0" r="0" t="0" b="0"/>
+          <a:blip r:embed="rId3"/>
+          <a:srcRect/>
           <a:stretch/>
         </p:blipFill>
         <p:spPr>
@@ -4597,7 +4441,7 @@
               </a:lnSpc>
             </a:pPr>
             <a:r>
-              <a:rPr lang="en-US" sz="1050" spc="53" kern="0" dirty="0">
+              <a:rPr lang="en-US" sz="1050" kern="0" spc="53" dirty="0">
                 <a:solidFill>
                   <a:srgbClr val="C4B7A6"/>
                 </a:solidFill>
@@ -4946,7 +4790,6 @@
   </p:clrMapOvr>
   <p:transition>
     <p:fade/>
-    <p:spd val="med"/>
   </p:transition>
 </p:sld>
 </file>
@@ -4959,6 +4802,7 @@
         <a:solidFill>
           <a:srgbClr val="FAF9F6"/>
         </a:solidFill>
+        <a:effectLst/>
       </p:bgPr>
     </p:bg>
     <p:spTree>
@@ -4977,22 +4821,22 @@
       </p:grpSpPr>
       <p:pic>
         <p:nvPicPr>
-          <p:cNvPr id="2" name="Image 0" descr="preencoded.png">    </p:cNvPr>
+          <p:cNvPr id="2" name="Image 0" descr="preencoded.png"/>
           <p:cNvPicPr>
             <a:picLocks noChangeAspect="1"/>
           </p:cNvPicPr>
           <p:nvPr/>
         </p:nvPicPr>
         <p:blipFill>
-          <a:blip r:embed="rId1">
+          <a:blip>
             <a:alphaModFix amt="4000"/>
             <a:extLst>
               <a:ext uri="{96DAC541-7B7A-43D3-8B79-37D633B846F1}">
-                <asvg:svgBlip xmlns:asvg="http://schemas.microsoft.com/office/drawing/2016/SVG/main" r:embed="rId2"/>
+                <asvg:svgBlip xmlns:asvg="http://schemas.microsoft.com/office/drawing/2016/SVG/main" r:embed="rId3"/>
               </a:ext>
             </a:extLst>
           </a:blip>
-          <a:srcRect l="0" r="0" t="0" b="0"/>
+          <a:srcRect/>
           <a:stretch/>
         </p:blipFill>
         <p:spPr>
@@ -6130,7 +5974,6 @@
   </p:clrMapOvr>
   <p:transition>
     <p:fade/>
-    <p:spd val="med"/>
   </p:transition>
 </p:sld>
 </file>
@@ -6143,6 +5986,7 @@
         <a:solidFill>
           <a:srgbClr val="FAF9F6"/>
         </a:solidFill>
+        <a:effectLst/>
       </p:bgPr>
     </p:bg>
     <p:spTree>
@@ -6230,7 +6074,7 @@
               </a:lnSpc>
             </a:pPr>
             <a:r>
-              <a:rPr lang="en-US" sz="1050" spc="210" kern="0" dirty="0">
+              <a:rPr lang="en-US" sz="1050" kern="0" spc="210" dirty="0">
                 <a:solidFill>
                   <a:srgbClr val="A8A29E"/>
                 </a:solidFill>
@@ -7765,10 +7609,18 @@
   <p:clrMapOvr>
     <a:masterClrMapping/>
   </p:clrMapOvr>
-  <p:transition>
-    <p:fade/>
-    <p:spd val="med"/>
-  </p:transition>
+  <mc:AlternateContent xmlns:mc="http://schemas.openxmlformats.org/markup-compatibility/2006">
+    <mc:Choice xmlns:p159="http://schemas.microsoft.com/office/powerpoint/2015/09/main" Requires="p159">
+      <p:transition xmlns:p14="http://schemas.microsoft.com/office/powerpoint/2010/main" spd="slow" p14:dur="2000">
+        <p159:morph option="byObject"/>
+      </p:transition>
+    </mc:Choice>
+    <mc:Fallback>
+      <p:transition spd="slow">
+        <p:fade/>
+      </p:transition>
+    </mc:Fallback>
+  </mc:AlternateContent>
 </p:sld>
 </file>
 
@@ -7780,6 +7632,7 @@
         <a:solidFill>
           <a:srgbClr val="FAF9F6"/>
         </a:solidFill>
+        <a:effectLst/>
       </p:bgPr>
     </p:bg>
     <p:spTree>
@@ -7867,7 +7720,7 @@
               </a:lnSpc>
             </a:pPr>
             <a:r>
-              <a:rPr lang="en-US" sz="1050" spc="210" kern="0" dirty="0">
+              <a:rPr lang="en-US" sz="1050" kern="0" spc="210" dirty="0">
                 <a:solidFill>
                   <a:srgbClr val="A8A29E"/>
                 </a:solidFill>
@@ -8047,11 +7900,6 @@
               </a:rPr>
               <a:t>Core Proposition:</a:t>
             </a:r>
-            <a:pPr>
-              <a:lnSpc>
-                <a:spcPct val="140000"/>
-              </a:lnSpc>
-            </a:pPr>
             <a:r>
               <a:rPr lang="en-US" sz="1500" dirty="0">
                 <a:solidFill>
@@ -10035,7 +9883,6 @@
   </p:clrMapOvr>
   <p:transition>
     <p:fade/>
-    <p:spd val="med"/>
   </p:transition>
 </p:sld>
 </file>
@@ -10048,6 +9895,7 @@
         <a:solidFill>
           <a:srgbClr val="FAF9F6"/>
         </a:solidFill>
+        <a:effectLst/>
       </p:bgPr>
     </p:bg>
     <p:spTree>
@@ -10135,7 +9983,7 @@
               </a:lnSpc>
             </a:pPr>
             <a:r>
-              <a:rPr lang="en-US" sz="1050" spc="210" kern="0" dirty="0">
+              <a:rPr lang="en-US" sz="1050" kern="0" spc="210" dirty="0">
                 <a:solidFill>
                   <a:srgbClr val="A8A29E"/>
                 </a:solidFill>
@@ -12105,7 +11953,6 @@
   </p:clrMapOvr>
   <p:transition>
     <p:fade/>
-    <p:spd val="med"/>
   </p:transition>
 </p:sld>
 </file>
@@ -12118,6 +11965,7 @@
         <a:solidFill>
           <a:srgbClr val="FAF9F6"/>
         </a:solidFill>
+        <a:effectLst/>
       </p:bgPr>
     </p:bg>
     <p:spTree>
@@ -12205,7 +12053,7 @@
               </a:lnSpc>
             </a:pPr>
             <a:r>
-              <a:rPr lang="en-US" sz="1050" spc="210" kern="0" dirty="0">
+              <a:rPr lang="en-US" sz="1050" kern="0" spc="210" dirty="0">
                 <a:solidFill>
                   <a:srgbClr val="A8A29E"/>
                 </a:solidFill>
@@ -12341,11 +12189,6 @@
               </a:rPr>
               <a:t>Working with a </a:t>
             </a:r>
-            <a:pPr>
-              <a:lnSpc>
-                <a:spcPct val="140000"/>
-              </a:lnSpc>
-            </a:pPr>
             <a:r>
               <a:rPr lang="en-US" sz="1350" b="1" dirty="0">
                 <a:solidFill>
@@ -12357,11 +12200,6 @@
               </a:rPr>
               <a:t>120,000-article frozen subset</a:t>
             </a:r>
-            <a:pPr>
-              <a:lnSpc>
-                <a:spcPct val="140000"/>
-              </a:lnSpc>
-            </a:pPr>
             <a:r>
               <a:rPr lang="en-US" sz="1350" dirty="0">
                 <a:solidFill>
@@ -12458,11 +12296,6 @@
               </a:rPr>
               <a:t>Assertion:</a:t>
             </a:r>
-            <a:pPr>
-              <a:lnSpc>
-                <a:spcPct val="140000"/>
-              </a:lnSpc>
-            </a:pPr>
             <a:r>
               <a:rPr lang="en-US" sz="1350" dirty="0">
                 <a:solidFill>
@@ -12569,7 +12402,7 @@
               </a:lnSpc>
             </a:pPr>
             <a:r>
-              <a:rPr lang="en-US" sz="1050" spc="53" kern="0" dirty="0">
+              <a:rPr lang="en-US" sz="1050" kern="0" spc="53" dirty="0">
                 <a:solidFill>
                   <a:srgbClr val="A8A29E"/>
                 </a:solidFill>
@@ -13804,7 +13637,6 @@
   </p:clrMapOvr>
   <p:transition>
     <p:fade/>
-    <p:spd val="med"/>
   </p:transition>
 </p:sld>
 </file>
@@ -13817,6 +13649,7 @@
         <a:solidFill>
           <a:srgbClr val="FAF9F6"/>
         </a:solidFill>
+        <a:effectLst/>
       </p:bgPr>
     </p:bg>
     <p:spTree>
@@ -13904,7 +13737,7 @@
               </a:lnSpc>
             </a:pPr>
             <a:r>
-              <a:rPr lang="en-US" sz="1050" spc="210" kern="0" dirty="0">
+              <a:rPr lang="en-US" sz="1050" kern="0" spc="210" dirty="0">
                 <a:solidFill>
                   <a:srgbClr val="A8A29E"/>
                 </a:solidFill>
@@ -15017,11 +14850,6 @@
               </a:rPr>
               <a:t>Reducing dimensionality guarantees that algorithmic pattern recognition focuses strictly on </a:t>
             </a:r>
-            <a:pPr>
-              <a:lnSpc>
-                <a:spcPct val="140000"/>
-              </a:lnSpc>
-            </a:pPr>
             <a:r>
               <a:rPr lang="en-US" sz="1200" dirty="0">
                 <a:solidFill>
@@ -15033,11 +14861,6 @@
               </a:rPr>
               <a:t>thematic terminologies</a:t>
             </a:r>
-            <a:pPr>
-              <a:lnSpc>
-                <a:spcPct val="140000"/>
-              </a:lnSpc>
-            </a:pPr>
             <a:r>
               <a:rPr lang="en-US" sz="1200" dirty="0">
                 <a:solidFill>
@@ -16031,7 +15854,6 @@
   </p:clrMapOvr>
   <p:transition>
     <p:fade/>
-    <p:spd val="med"/>
   </p:transition>
 </p:sld>
 </file>
@@ -16044,6 +15866,7 @@
         <a:solidFill>
           <a:srgbClr val="FAF9F6"/>
         </a:solidFill>
+        <a:effectLst/>
       </p:bgPr>
     </p:bg>
     <p:spTree>
@@ -16131,7 +15954,7 @@
               </a:lnSpc>
             </a:pPr>
             <a:r>
-              <a:rPr lang="en-US" sz="1050" spc="210" kern="0" dirty="0">
+              <a:rPr lang="en-US" sz="1050" kern="0" spc="210" dirty="0">
                 <a:solidFill>
                   <a:srgbClr val="A8A29E"/>
                 </a:solidFill>
@@ -16232,21 +16055,21 @@
       </p:sp>
       <p:pic>
         <p:nvPicPr>
-          <p:cNvPr id="6" name="Image 0" descr="preencoded.png">    </p:cNvPr>
+          <p:cNvPr id="6" name="Image 0" descr="preencoded.png"/>
           <p:cNvPicPr>
             <a:picLocks noChangeAspect="1"/>
           </p:cNvPicPr>
           <p:nvPr/>
         </p:nvPicPr>
         <p:blipFill>
-          <a:blip r:embed="rId1">
+          <a:blip>
             <a:extLst>
               <a:ext uri="{96DAC541-7B7A-43D3-8B79-37D633B846F1}">
-                <asvg:svgBlip xmlns:asvg="http://schemas.microsoft.com/office/drawing/2016/SVG/main" r:embed="rId2"/>
+                <asvg:svgBlip xmlns:asvg="http://schemas.microsoft.com/office/drawing/2016/SVG/main" r:embed="rId3"/>
               </a:ext>
             </a:extLst>
           </a:blip>
-          <a:srcRect l="0" r="0" t="0" b="0"/>
+          <a:srcRect/>
           <a:stretch/>
         </p:blipFill>
         <p:spPr>
@@ -16370,7 +16193,7 @@
               </a:lnSpc>
             </a:pPr>
             <a:r>
-              <a:rPr lang="en-US" sz="1050" spc="53" kern="0" dirty="0">
+              <a:rPr lang="en-US" sz="1050" kern="0" spc="53" dirty="0">
                 <a:solidFill>
                   <a:srgbClr val="8B8680"/>
                 </a:solidFill>
@@ -16452,7 +16275,7 @@
               </a:lnSpc>
             </a:pPr>
             <a:r>
-              <a:rPr lang="en-US" sz="1050" spc="53" kern="0" dirty="0">
+              <a:rPr lang="en-US" sz="1050" kern="0" spc="53" dirty="0">
                 <a:solidFill>
                   <a:srgbClr val="8B8680"/>
                 </a:solidFill>
@@ -16553,21 +16376,21 @@
       </p:sp>
       <p:pic>
         <p:nvPicPr>
-          <p:cNvPr id="14" name="Image 1" descr="preencoded.png">    </p:cNvPr>
+          <p:cNvPr id="14" name="Image 1" descr="preencoded.png"/>
           <p:cNvPicPr>
             <a:picLocks noChangeAspect="1"/>
           </p:cNvPicPr>
           <p:nvPr/>
         </p:nvPicPr>
         <p:blipFill>
-          <a:blip r:embed="rId3">
+          <a:blip>
             <a:extLst>
               <a:ext uri="{96DAC541-7B7A-43D3-8B79-37D633B846F1}">
                 <asvg:svgBlip xmlns:asvg="http://schemas.microsoft.com/office/drawing/2016/SVG/main" r:embed="rId4"/>
               </a:ext>
             </a:extLst>
           </a:blip>
-          <a:srcRect l="0" r="0" t="0" b="0"/>
+          <a:srcRect/>
           <a:stretch/>
         </p:blipFill>
         <p:spPr>
@@ -16691,7 +16514,7 @@
               </a:lnSpc>
             </a:pPr>
             <a:r>
-              <a:rPr lang="en-US" sz="1050" spc="53" kern="0" dirty="0">
+              <a:rPr lang="en-US" sz="1050" kern="0" spc="53" dirty="0">
                 <a:solidFill>
                   <a:srgbClr val="C4B7A6"/>
                 </a:solidFill>
@@ -16773,7 +16596,7 @@
               </a:lnSpc>
             </a:pPr>
             <a:r>
-              <a:rPr lang="en-US" sz="1050" spc="53" kern="0" dirty="0">
+              <a:rPr lang="en-US" sz="1050" kern="0" spc="53" dirty="0">
                 <a:solidFill>
                   <a:srgbClr val="C4B7A6"/>
                 </a:solidFill>
@@ -16874,21 +16697,21 @@
       </p:sp>
       <p:pic>
         <p:nvPicPr>
-          <p:cNvPr id="22" name="Image 2" descr="preencoded.png">    </p:cNvPr>
+          <p:cNvPr id="22" name="Image 2" descr="preencoded.png"/>
           <p:cNvPicPr>
             <a:picLocks noChangeAspect="1"/>
           </p:cNvPicPr>
           <p:nvPr/>
         </p:nvPicPr>
         <p:blipFill>
-          <a:blip r:embed="rId5">
+          <a:blip>
             <a:extLst>
               <a:ext uri="{96DAC541-7B7A-43D3-8B79-37D633B846F1}">
-                <asvg:svgBlip xmlns:asvg="http://schemas.microsoft.com/office/drawing/2016/SVG/main" r:embed="rId6"/>
+                <asvg:svgBlip xmlns:asvg="http://schemas.microsoft.com/office/drawing/2016/SVG/main" r:embed="rId5"/>
               </a:ext>
             </a:extLst>
           </a:blip>
-          <a:srcRect l="0" r="0" t="0" b="0"/>
+          <a:srcRect/>
           <a:stretch/>
         </p:blipFill>
         <p:spPr>
@@ -17012,7 +16835,7 @@
               </a:lnSpc>
             </a:pPr>
             <a:r>
-              <a:rPr lang="en-US" sz="1050" spc="53" kern="0" dirty="0">
+              <a:rPr lang="en-US" sz="1050" kern="0" spc="53" dirty="0">
                 <a:solidFill>
                   <a:srgbClr val="A8A29E"/>
                 </a:solidFill>
@@ -17094,7 +16917,7 @@
               </a:lnSpc>
             </a:pPr>
             <a:r>
-              <a:rPr lang="en-US" sz="1050" spc="53" kern="0" dirty="0">
+              <a:rPr lang="en-US" sz="1050" kern="0" spc="53" dirty="0">
                 <a:solidFill>
                   <a:srgbClr val="A8A29E"/>
                 </a:solidFill>
@@ -17156,7 +16979,6 @@
   </p:clrMapOvr>
   <p:transition>
     <p:fade/>
-    <p:spd val="med"/>
   </p:transition>
 </p:sld>
 </file>
@@ -17169,6 +16991,7 @@
         <a:solidFill>
           <a:srgbClr val="FAF9F6"/>
         </a:solidFill>
+        <a:effectLst/>
       </p:bgPr>
     </p:bg>
     <p:spTree>
@@ -17256,7 +17079,7 @@
               </a:lnSpc>
             </a:pPr>
             <a:r>
-              <a:rPr lang="en-US" sz="1050" spc="210" kern="0" dirty="0">
+              <a:rPr lang="en-US" sz="1050" kern="0" spc="210" dirty="0">
                 <a:solidFill>
                   <a:srgbClr val="A8A29E"/>
                 </a:solidFill>
@@ -17392,11 +17215,6 @@
               </a:rPr>
               <a:t>Executing </a:t>
             </a:r>
-            <a:pPr>
-              <a:lnSpc>
-                <a:spcPct val="140000"/>
-              </a:lnSpc>
-            </a:pPr>
             <a:r>
               <a:rPr lang="en-US" sz="1350" b="1" dirty="0">
                 <a:solidFill>
@@ -17408,11 +17226,6 @@
               </a:rPr>
               <a:t>K-Means and DBSCAN clustering</a:t>
             </a:r>
-            <a:pPr>
-              <a:lnSpc>
-                <a:spcPct val="140000"/>
-              </a:lnSpc>
-            </a:pPr>
             <a:r>
               <a:rPr lang="en-US" sz="1350" dirty="0">
                 <a:solidFill>
@@ -17769,21 +17582,21 @@
       </p:sp>
       <p:pic>
         <p:nvPicPr>
-          <p:cNvPr id="15" name="Image 0" descr="preencoded.png">    </p:cNvPr>
+          <p:cNvPr id="15" name="Image 0" descr="preencoded.png"/>
           <p:cNvPicPr>
             <a:picLocks noChangeAspect="1"/>
           </p:cNvPicPr>
           <p:nvPr/>
         </p:nvPicPr>
         <p:blipFill>
-          <a:blip r:embed="rId1">
+          <a:blip>
             <a:extLst>
               <a:ext uri="{96DAC541-7B7A-43D3-8B79-37D633B846F1}">
-                <asvg:svgBlip xmlns:asvg="http://schemas.microsoft.com/office/drawing/2016/SVG/main" r:embed="rId2"/>
+                <asvg:svgBlip xmlns:asvg="http://schemas.microsoft.com/office/drawing/2016/SVG/main" r:embed="rId3"/>
               </a:ext>
             </a:extLst>
           </a:blip>
-          <a:srcRect l="0" r="0" t="8333" b="8333"/>
+          <a:srcRect t="8333" b="8333"/>
           <a:stretch/>
         </p:blipFill>
         <p:spPr>
@@ -17805,7 +17618,6 @@
   </p:clrMapOvr>
   <p:transition>
     <p:fade/>
-    <p:spd val="med"/>
   </p:transition>
 </p:sld>
 </file>
@@ -17818,6 +17630,7 @@
         <a:solidFill>
           <a:srgbClr val="FAF9F6"/>
         </a:solidFill>
+        <a:effectLst/>
       </p:bgPr>
     </p:bg>
     <p:spTree>
@@ -17905,7 +17718,7 @@
               </a:lnSpc>
             </a:pPr>
             <a:r>
-              <a:rPr lang="en-US" sz="1050" spc="210" kern="0" dirty="0">
+              <a:rPr lang="en-US" sz="1050" kern="0" spc="210" dirty="0">
                 <a:solidFill>
                   <a:srgbClr val="A8A29E"/>
                 </a:solidFill>
@@ -17962,21 +17775,21 @@
       </p:sp>
       <p:pic>
         <p:nvPicPr>
-          <p:cNvPr id="5" name="Image 0" descr="preencoded.png">    </p:cNvPr>
+          <p:cNvPr id="5" name="Image 0" descr="preencoded.png"/>
           <p:cNvPicPr>
             <a:picLocks noChangeAspect="1"/>
           </p:cNvPicPr>
           <p:nvPr/>
         </p:nvPicPr>
         <p:blipFill>
-          <a:blip r:embed="rId1">
+          <a:blip>
             <a:extLst>
               <a:ext uri="{96DAC541-7B7A-43D3-8B79-37D633B846F1}">
-                <asvg:svgBlip xmlns:asvg="http://schemas.microsoft.com/office/drawing/2016/SVG/main" r:embed="rId2"/>
+                <asvg:svgBlip xmlns:asvg="http://schemas.microsoft.com/office/drawing/2016/SVG/main" r:embed="rId3"/>
               </a:ext>
             </a:extLst>
           </a:blip>
-          <a:srcRect l="0" r="0" t="0" b="0"/>
+          <a:srcRect/>
           <a:stretch/>
         </p:blipFill>
         <p:spPr>
@@ -18205,7 +18018,7 @@
               </a:lnSpc>
             </a:pPr>
             <a:r>
-              <a:rPr lang="en-US" sz="1050" spc="53" kern="0" dirty="0">
+              <a:rPr lang="en-US" sz="1050" kern="0" spc="53" dirty="0">
                 <a:solidFill>
                   <a:srgbClr val="A8A29E"/>
                 </a:solidFill>
@@ -18262,21 +18075,21 @@
       </p:sp>
       <p:pic>
         <p:nvPicPr>
-          <p:cNvPr id="12" name="Image 1" descr="preencoded.png">    </p:cNvPr>
+          <p:cNvPr id="12" name="Image 1" descr="preencoded.png"/>
           <p:cNvPicPr>
             <a:picLocks noChangeAspect="1"/>
           </p:cNvPicPr>
           <p:nvPr/>
         </p:nvPicPr>
         <p:blipFill>
-          <a:blip r:embed="rId3">
+          <a:blip>
             <a:extLst>
               <a:ext uri="{96DAC541-7B7A-43D3-8B79-37D633B846F1}">
                 <asvg:svgBlip xmlns:asvg="http://schemas.microsoft.com/office/drawing/2016/SVG/main" r:embed="rId4"/>
               </a:ext>
             </a:extLst>
           </a:blip>
-          <a:srcRect l="0" r="0" t="0" b="0"/>
+          <a:srcRect/>
           <a:stretch/>
         </p:blipFill>
         <p:spPr>
@@ -18591,7 +18404,6 @@
   </p:clrMapOvr>
   <p:transition>
     <p:fade/>
-    <p:spd val="med"/>
   </p:transition>
 </p:sld>
 </file>
@@ -18604,31 +18416,326 @@
         <a:srgbClr val="000000"/>
       </a:dk1>
       <a:lt1>
-        <a:srgbClr val="ffffff"/>
+        <a:srgbClr val="FFFFFF"/>
       </a:lt1>
       <a:dk2>
         <a:srgbClr val="333333"/>
       </a:dk2>
       <a:lt2>
-        <a:srgbClr val="eeeeee"/>
+        <a:srgbClr val="EEEEEE"/>
       </a:lt2>
       <a:accent1>
-        <a:srgbClr val="8daac2"/>
+        <a:srgbClr val="8DAAC2"/>
       </a:accent1>
       <a:accent2>
-        <a:srgbClr val="ed7d31"/>
+        <a:srgbClr val="ED7D31"/>
       </a:accent2>
       <a:accent3>
-        <a:srgbClr val="a5a5a5"/>
+        <a:srgbClr val="A5A5A5"/>
       </a:accent3>
       <a:accent4>
-        <a:srgbClr val="ffc000"/>
+        <a:srgbClr val="FFC000"/>
       </a:accent4>
       <a:accent5>
-        <a:srgbClr val="4472c4"/>
+        <a:srgbClr val="4472C4"/>
       </a:accent5>
       <a:accent6>
-        <a:srgbClr val="70ad47"/>
+        <a:srgbClr val="70AD47"/>
+      </a:accent6>
+      <a:hlink>
+        <a:srgbClr val="0563C1"/>
+      </a:hlink>
+      <a:folHlink>
+        <a:srgbClr val="954F72"/>
+      </a:folHlink>
+    </a:clrScheme>
+    <a:fontScheme name="Office">
+      <a:majorFont>
+        <a:latin typeface="Calibri Light" panose="020F0302020204030204"/>
+        <a:ea typeface=""/>
+        <a:cs typeface=""/>
+        <a:font script="Jpan" typeface="游ゴシック Light"/>
+        <a:font script="Hang" typeface="맑은 고딕"/>
+        <a:font script="Hans" typeface="等线 Light"/>
+        <a:font script="Hant" typeface="新細明體"/>
+        <a:font script="Arab" typeface="Times New Roman"/>
+        <a:font script="Hebr" typeface="Times New Roman"/>
+        <a:font script="Thai" typeface="Angsana New"/>
+        <a:font script="Ethi" typeface="Nyala"/>
+        <a:font script="Beng" typeface="Vrinda"/>
+        <a:font script="Gujr" typeface="Shruti"/>
+        <a:font script="Khmr" typeface="MoolBoran"/>
+        <a:font script="Knda" typeface="Tunga"/>
+        <a:font script="Guru" typeface="Raavi"/>
+        <a:font script="Cans" typeface="Euphemia"/>
+        <a:font script="Cher" typeface="Plantagenet Cherokee"/>
+        <a:font script="Yiii" typeface="Microsoft Yi Baiti"/>
+        <a:font script="Tibt" typeface="Microsoft Himalaya"/>
+        <a:font script="Thaa" typeface="MV Boli"/>
+        <a:font script="Deva" typeface="Mangal"/>
+        <a:font script="Telu" typeface="Gautami"/>
+        <a:font script="Taml" typeface="Latha"/>
+        <a:font script="Syrc" typeface="Estrangelo Edessa"/>
+        <a:font script="Orya" typeface="Kalinga"/>
+        <a:font script="Mlym" typeface="Kartika"/>
+        <a:font script="Laoo" typeface="DokChampa"/>
+        <a:font script="Sinh" typeface="Iskoola Pota"/>
+        <a:font script="Mong" typeface="Mongolian Baiti"/>
+        <a:font script="Viet" typeface="Times New Roman"/>
+        <a:font script="Uigh" typeface="Microsoft Uighur"/>
+        <a:font script="Geor" typeface="Sylfaen"/>
+        <a:font script="Armn" typeface="Arial"/>
+        <a:font script="Bugi" typeface="Leelawadee UI"/>
+        <a:font script="Bopo" typeface="Microsoft JhengHei"/>
+        <a:font script="Java" typeface="Javanese Text"/>
+        <a:font script="Lisu" typeface="Segoe UI"/>
+        <a:font script="Mymr" typeface="Myanmar Text"/>
+        <a:font script="Nkoo" typeface="Ebrima"/>
+        <a:font script="Olck" typeface="Nirmala UI"/>
+        <a:font script="Osma" typeface="Ebrima"/>
+        <a:font script="Phag" typeface="Phagspa"/>
+        <a:font script="Syrn" typeface="Estrangelo Edessa"/>
+        <a:font script="Syrj" typeface="Estrangelo Edessa"/>
+        <a:font script="Syre" typeface="Estrangelo Edessa"/>
+        <a:font script="Sora" typeface="Nirmala UI"/>
+        <a:font script="Tale" typeface="Microsoft Tai Le"/>
+        <a:font script="Talu" typeface="Microsoft New Tai Lue"/>
+        <a:font script="Tfng" typeface="Ebrima"/>
+      </a:majorFont>
+      <a:minorFont>
+        <a:latin typeface="Calibri" panose="020F0502020204030204"/>
+        <a:ea typeface=""/>
+        <a:cs typeface=""/>
+        <a:font script="Jpan" typeface="游ゴシック"/>
+        <a:font script="Hang" typeface="맑은 고딕"/>
+        <a:font script="Hans" typeface="等线"/>
+        <a:font script="Hant" typeface="新細明體"/>
+        <a:font script="Arab" typeface="Arial"/>
+        <a:font script="Hebr" typeface="Arial"/>
+        <a:font script="Thai" typeface="Cordia New"/>
+        <a:font script="Ethi" typeface="Nyala"/>
+        <a:font script="Beng" typeface="Vrinda"/>
+        <a:font script="Gujr" typeface="Shruti"/>
+        <a:font script="Khmr" typeface="DaunPenh"/>
+        <a:font script="Knda" typeface="Tunga"/>
+        <a:font script="Guru" typeface="Raavi"/>
+        <a:font script="Cans" typeface="Euphemia"/>
+        <a:font script="Cher" typeface="Plantagenet Cherokee"/>
+        <a:font script="Yiii" typeface="Microsoft Yi Baiti"/>
+        <a:font script="Tibt" typeface="Microsoft Himalaya"/>
+        <a:font script="Thaa" typeface="MV Boli"/>
+        <a:font script="Deva" typeface="Mangal"/>
+        <a:font script="Telu" typeface="Gautami"/>
+        <a:font script="Taml" typeface="Latha"/>
+        <a:font script="Syrc" typeface="Estrangelo Edessa"/>
+        <a:font script="Orya" typeface="Kalinga"/>
+        <a:font script="Mlym" typeface="Kartika"/>
+        <a:font script="Laoo" typeface="DokChampa"/>
+        <a:font script="Sinh" typeface="Iskoola Pota"/>
+        <a:font script="Mong" typeface="Mongolian Baiti"/>
+        <a:font script="Viet" typeface="Arial"/>
+        <a:font script="Uigh" typeface="Microsoft Uighur"/>
+        <a:font script="Geor" typeface="Sylfaen"/>
+        <a:font script="Armn" typeface="Arial"/>
+        <a:font script="Bugi" typeface="Leelawadee UI"/>
+        <a:font script="Bopo" typeface="Microsoft JhengHei"/>
+        <a:font script="Java" typeface="Javanese Text"/>
+        <a:font script="Lisu" typeface="Segoe UI"/>
+        <a:font script="Mymr" typeface="Myanmar Text"/>
+        <a:font script="Nkoo" typeface="Ebrima"/>
+        <a:font script="Olck" typeface="Nirmala UI"/>
+        <a:font script="Osma" typeface="Ebrima"/>
+        <a:font script="Phag" typeface="Phagspa"/>
+        <a:font script="Syrn" typeface="Estrangelo Edessa"/>
+        <a:font script="Syrj" typeface="Estrangelo Edessa"/>
+        <a:font script="Syre" typeface="Estrangelo Edessa"/>
+        <a:font script="Sora" typeface="Nirmala UI"/>
+        <a:font script="Tale" typeface="Microsoft Tai Le"/>
+        <a:font script="Talu" typeface="Microsoft New Tai Lue"/>
+        <a:font script="Tfng" typeface="Ebrima"/>
+      </a:minorFont>
+    </a:fontScheme>
+    <a:fmtScheme name="Office">
+      <a:fillStyleLst>
+        <a:solidFill>
+          <a:schemeClr val="phClr"/>
+        </a:solidFill>
+        <a:gradFill rotWithShape="1">
+          <a:gsLst>
+            <a:gs pos="0">
+              <a:schemeClr val="phClr">
+                <a:lumMod val="110000"/>
+                <a:satMod val="105000"/>
+                <a:tint val="67000"/>
+              </a:schemeClr>
+            </a:gs>
+            <a:gs pos="50000">
+              <a:schemeClr val="phClr">
+                <a:lumMod val="105000"/>
+                <a:satMod val="103000"/>
+                <a:tint val="73000"/>
+              </a:schemeClr>
+            </a:gs>
+            <a:gs pos="100000">
+              <a:schemeClr val="phClr">
+                <a:lumMod val="105000"/>
+                <a:satMod val="109000"/>
+                <a:tint val="81000"/>
+              </a:schemeClr>
+            </a:gs>
+          </a:gsLst>
+          <a:lin ang="5400000" scaled="0"/>
+        </a:gradFill>
+        <a:gradFill rotWithShape="1">
+          <a:gsLst>
+            <a:gs pos="0">
+              <a:schemeClr val="phClr">
+                <a:satMod val="103000"/>
+                <a:lumMod val="102000"/>
+                <a:tint val="94000"/>
+              </a:schemeClr>
+            </a:gs>
+            <a:gs pos="50000">
+              <a:schemeClr val="phClr">
+                <a:satMod val="110000"/>
+                <a:lumMod val="100000"/>
+                <a:shade val="100000"/>
+              </a:schemeClr>
+            </a:gs>
+            <a:gs pos="100000">
+              <a:schemeClr val="phClr">
+                <a:lumMod val="99000"/>
+                <a:satMod val="120000"/>
+                <a:shade val="78000"/>
+              </a:schemeClr>
+            </a:gs>
+          </a:gsLst>
+          <a:lin ang="5400000" scaled="0"/>
+        </a:gradFill>
+      </a:fillStyleLst>
+      <a:lnStyleLst>
+        <a:ln w="6350" cap="flat" cmpd="sng" algn="ctr">
+          <a:solidFill>
+            <a:schemeClr val="phClr"/>
+          </a:solidFill>
+          <a:prstDash val="solid"/>
+          <a:miter lim="800000"/>
+        </a:ln>
+        <a:ln w="12700" cap="flat" cmpd="sng" algn="ctr">
+          <a:solidFill>
+            <a:schemeClr val="phClr"/>
+          </a:solidFill>
+          <a:prstDash val="solid"/>
+          <a:miter lim="800000"/>
+        </a:ln>
+        <a:ln w="19050" cap="flat" cmpd="sng" algn="ctr">
+          <a:solidFill>
+            <a:schemeClr val="phClr"/>
+          </a:solidFill>
+          <a:prstDash val="solid"/>
+          <a:miter lim="800000"/>
+        </a:ln>
+      </a:lnStyleLst>
+      <a:effectStyleLst>
+        <a:effectStyle>
+          <a:effectLst/>
+        </a:effectStyle>
+        <a:effectStyle>
+          <a:effectLst/>
+        </a:effectStyle>
+        <a:effectStyle>
+          <a:effectLst>
+            <a:outerShdw blurRad="57150" dist="19050" dir="5400000" algn="ctr" rotWithShape="0">
+              <a:srgbClr val="000000">
+                <a:alpha val="63000"/>
+              </a:srgbClr>
+            </a:outerShdw>
+          </a:effectLst>
+        </a:effectStyle>
+      </a:effectStyleLst>
+      <a:bgFillStyleLst>
+        <a:solidFill>
+          <a:schemeClr val="phClr"/>
+        </a:solidFill>
+        <a:solidFill>
+          <a:schemeClr val="phClr">
+            <a:tint val="95000"/>
+            <a:satMod val="170000"/>
+          </a:schemeClr>
+        </a:solidFill>
+        <a:gradFill rotWithShape="1">
+          <a:gsLst>
+            <a:gs pos="0">
+              <a:schemeClr val="phClr">
+                <a:tint val="93000"/>
+                <a:satMod val="150000"/>
+                <a:shade val="98000"/>
+                <a:lumMod val="102000"/>
+              </a:schemeClr>
+            </a:gs>
+            <a:gs pos="50000">
+              <a:schemeClr val="phClr">
+                <a:tint val="98000"/>
+                <a:satMod val="130000"/>
+                <a:shade val="90000"/>
+                <a:lumMod val="103000"/>
+              </a:schemeClr>
+            </a:gs>
+            <a:gs pos="100000">
+              <a:schemeClr val="phClr">
+                <a:shade val="63000"/>
+                <a:satMod val="120000"/>
+              </a:schemeClr>
+            </a:gs>
+          </a:gsLst>
+          <a:lin ang="5400000" scaled="0"/>
+        </a:gradFill>
+      </a:bgFillStyleLst>
+    </a:fmtScheme>
+  </a:themeElements>
+  <a:objectDefaults/>
+  <a:extraClrSchemeLst/>
+  <a:extLst>
+    <a:ext uri="{05A4C25C-085E-4340-85A3-A5531E510DB2}">
+      <thm15:themeFamily xmlns:thm15="http://schemas.microsoft.com/office/thememl/2012/main" name="Office Theme" id="{62F939B6-93AF-4DB8-9C6B-D6C7DFDC589F}" vid="{4A3C46E8-61CC-4603-A589-7422A47A8E4A}"/>
+    </a:ext>
+  </a:extLst>
+</a:theme>
+</file>
+
+<file path=ppt/theme/theme2.xml><?xml version="1.0" encoding="utf-8"?>
+<a:theme xmlns:a="http://schemas.openxmlformats.org/drawingml/2006/main" name="Office Theme">
+  <a:themeElements>
+    <a:clrScheme name="Office">
+      <a:dk1>
+        <a:sysClr val="windowText" lastClr="000000"/>
+      </a:dk1>
+      <a:lt1>
+        <a:sysClr val="window" lastClr="FFFFFF"/>
+      </a:lt1>
+      <a:dk2>
+        <a:srgbClr val="44546A"/>
+      </a:dk2>
+      <a:lt2>
+        <a:srgbClr val="E7E6E6"/>
+      </a:lt2>
+      <a:accent1>
+        <a:srgbClr val="4472C4"/>
+      </a:accent1>
+      <a:accent2>
+        <a:srgbClr val="ED7D31"/>
+      </a:accent2>
+      <a:accent3>
+        <a:srgbClr val="A5A5A5"/>
+      </a:accent3>
+      <a:accent4>
+        <a:srgbClr val="FFC000"/>
+      </a:accent4>
+      <a:accent5>
+        <a:srgbClr val="5B9BD5"/>
+      </a:accent5>
+      <a:accent6>
+        <a:srgbClr val="70AD47"/>
       </a:accent6>
       <a:hlink>
         <a:srgbClr val="0563C1"/>

</xml_diff>